<commit_message>
Manual deck: document the Reports & Analytics screen under More
Live verification of the remaining screens (Visitors, Referrals, Branches,
Import Data, Personal Training, Leads pipeline/workflow/follow-ups, member
detail, PT Feedback/Recognition) confirmed all of them against the deck.
The one gap found: More -> Money and oversight -> Reports opens a distinct
"Reports & Analytics" screen duplicating Analytics -> Business's charts
plus a per-plan Members/Revenue/Sold table, not previously mentioned.

Co-Authored-By: Claude Sonnet 5 <noreply@anthropic.com>
</commit_message>
<xml_diff>
--- a/docs/manual-deck/regulars-manual.pptx
+++ b/docs/manual-deck/regulars-manual.pptx
@@ -12348,6 +12348,44 @@
                 <a:cs typeface="Calibri" pitchFamily="34" charset="-120"/>
               </a:rPr>
               <a:t>If a fifth view appears later, it belongs here too, not a new corner</a:t>
+            </a:r>
+            <a:endParaRPr lang="en-US" sz="1250" dirty="0"/>
+          </a:p>
+          <a:p>
+            <a:pPr marL="177800" indent="-177800">
+              <a:spcAft>
+                <a:spcPts val="800"/>
+              </a:spcAft>
+              <a:buSzPct val="100000"/>
+              <a:buChar char="•"/>
+            </a:pPr>
+            <a:r>
+              <a:rPr lang="en-US" sz="1250" b="1" dirty="0">
+                <a:solidFill>
+                  <a:srgbClr val="12203D"/>
+                </a:solidFill>
+                <a:latin typeface="Calibri" pitchFamily="34" charset="0"/>
+                <a:ea typeface="Calibri" pitchFamily="34" charset="-122"/>
+                <a:cs typeface="Calibri" pitchFamily="34" charset="-120"/>
+              </a:rPr>
+              <a:t>Also findable as “Reports” under More — </a:t>
+            </a:r>
+            <a:pPr indent="0" marL="0">
+              <a:spcAft>
+                <a:spcPts val="800"/>
+              </a:spcAft>
+              <a:buNone/>
+            </a:pPr>
+            <a:r>
+              <a:rPr lang="en-US" sz="1250" dirty="0">
+                <a:solidFill>
+                  <a:srgbClr val="1C2536"/>
+                </a:solidFill>
+                <a:latin typeface="Calibri" pitchFamily="34" charset="0"/>
+                <a:ea typeface="Calibri" pitchFamily="34" charset="-122"/>
+                <a:cs typeface="Calibri" pitchFamily="34" charset="-120"/>
+              </a:rPr>
+              <a:t>same Business charts, plus a per-plan Members/Revenue/Sold table</a:t>
             </a:r>
             <a:endParaRPr lang="en-US" sz="1250" dirty="0"/>
           </a:p>

</xml_diff>

<commit_message>
Manual deck: add ezegym-style one-page feature checklist
Two-column checkmark list of 24 real, verified features, styled after
the ezegym.com pricing-page reference the user shared. Placed right
before Quick Reference, now 34 slides total.

Co-Authored-By: Claude Sonnet 5 <noreply@anthropic.com>
</commit_message>
<xml_diff>
--- a/docs/manual-deck/regulars-manual.pptx
+++ b/docs/manual-deck/regulars-manual.pptx
@@ -38,9 +38,10 @@
     <p:sldId id="286" r:id="rId32"/>
     <p:sldId id="287" r:id="rId33"/>
     <p:sldId id="288" r:id="rId34"/>
+    <p:sldId id="289" r:id="rId35"/>
   </p:sldIdLst>
   <p:notesMasterIdLst>
-    <p:notesMasterId r:id="rId35"/>
+    <p:notesMasterId r:id="rId36"/>
   </p:notesMasterIdLst>
   <p:sldSz cx="12192000" cy="6858000"/>
   <p:notesSz cx="6858000" cy="12192000"/>
@@ -2846,6 +2847,94 @@
             <a:fld id="{F7021451-1387-4CA6-816F-3879F97B5CBC}" type="slidenum">
               <a:rPr lang="en-US"/>
               <a:t>33</a:t>
+            </a:fld>
+            <a:endParaRPr lang="en-US"/>
+          </a:p>
+        </p:txBody>
+      </p:sp>
+    </p:spTree>
+    <p:extLst>
+      <p:ext uri="{BB962C8B-B14F-4D97-AF65-F5344CB8AC3E}">
+        <p14:creationId xmlns:p14="http://schemas.microsoft.com/office/powerpoint/2010/main" val="1024086991"/>
+      </p:ext>
+    </p:extLst>
+  </p:cSld>
+  <p:clrMapOvr>
+    <a:masterClrMapping/>
+  </p:clrMapOvr>
+</p:notes>
+</file>
+
+<file path=ppt/notesSlides/notesSlide34.xml><?xml version="1.0" encoding="utf-8"?>
+<p:notes xmlns:a="http://schemas.openxmlformats.org/drawingml/2006/main" xmlns:r="http://schemas.openxmlformats.org/officeDocument/2006/relationships" xmlns:p="http://schemas.openxmlformats.org/presentationml/2006/main">
+  <p:cSld>
+    <p:spTree>
+      <p:nvGrpSpPr>
+        <p:cNvPr id="1" name=""/>
+        <p:cNvGrpSpPr/>
+        <p:nvPr/>
+      </p:nvGrpSpPr>
+      <p:grpSpPr>
+        <a:xfrm>
+          <a:off x="0" y="0"/>
+          <a:ext cx="0" cy="0"/>
+          <a:chOff x="0" y="0"/>
+          <a:chExt cx="0" cy="0"/>
+        </a:xfrm>
+      </p:grpSpPr>
+      <p:sp>
+        <p:nvSpPr>
+          <p:cNvPr id="2" name="Slide Image Placeholder 1"/>
+          <p:cNvSpPr>
+            <a:spLocks noGrp="1" noRot="1" noChangeAspect="1"/>
+          </p:cNvSpPr>
+          <p:nvPr>
+            <p:ph type="sldImg"/>
+          </p:nvPr>
+        </p:nvSpPr>
+        <p:spPr/>
+      </p:sp>
+      <p:sp>
+        <p:nvSpPr>
+          <p:cNvPr id="3" name="Notes Placeholder 2"/>
+          <p:cNvSpPr>
+            <a:spLocks noGrp="1"/>
+          </p:cNvSpPr>
+          <p:nvPr>
+            <p:ph type="body" idx="1"/>
+          </p:nvPr>
+        </p:nvSpPr>
+        <p:spPr/>
+        <p:txBody>
+          <a:bodyPr/>
+          <a:lstStyle/>
+          <a:p>
+            <a:r>
+              <a:rPr lang="en-US" dirty="0"/>
+              <a:t/>
+            </a:r>
+            <a:endParaRPr lang="en-US" dirty="0"/>
+          </a:p>
+        </p:txBody>
+      </p:sp>
+      <p:sp>
+        <p:nvSpPr>
+          <p:cNvPr id="4" name="Slide Number Placeholder 3"/>
+          <p:cNvSpPr>
+            <a:spLocks noGrp="1"/>
+          </p:cNvSpPr>
+          <p:nvPr>
+            <p:ph type="sldNum" sz="quarter" idx="10"/>
+          </p:nvPr>
+        </p:nvSpPr>
+        <p:spPr/>
+        <p:txBody>
+          <a:bodyPr/>
+          <a:lstStyle/>
+          <a:p>
+            <a:fld id="{F7021451-1387-4CA6-816F-3879F97B5CBC}" type="slidenum">
+              <a:rPr lang="en-US"/>
+              <a:t>34</a:t>
             </a:fld>
             <a:endParaRPr lang="en-US"/>
           </a:p>
@@ -18820,7 +18909,7 @@
                 <a:ea typeface="Cambria" pitchFamily="34" charset="-122"/>
                 <a:cs typeface="Cambria" pitchFamily="34" charset="-120"/>
               </a:rPr>
-              <a:t>Quick Reference</a:t>
+              <a:t>The Complete Feature List</a:t>
             </a:r>
             <a:endParaRPr lang="en-US" sz="3000" dirty="0"/>
           </a:p>
@@ -18859,7 +18948,7 @@
                 <a:ea typeface="Calibri" pitchFamily="34" charset="-122"/>
                 <a:cs typeface="Calibri" pitchFamily="34" charset="-120"/>
               </a:rPr>
-              <a:t>The fastest way from “I want to…” to the right screen.</a:t>
+              <a:t>Every module in this manual, one page — nothing here that isn't a real, working screen.</a:t>
             </a:r>
             <a:endParaRPr lang="en-US" sz="1450" dirty="0"/>
           </a:p>
@@ -18909,9 +18998,1163 @@
           </a:prstGeom>
         </p:spPr>
       </p:pic>
+      <p:sp>
+        <p:nvSpPr>
+          <p:cNvPr id="7" name="Text 4"/>
+          <p:cNvSpPr txBox="1"/>
+          <p:nvPr/>
+        </p:nvSpPr>
+        <p:spPr>
+          <a:xfrm>
+            <a:off x="548640" y="1874520"/>
+            <a:ext cx="5318608" cy="4434840"/>
+          </a:xfrm>
+          <a:prstGeom prst="rect">
+            <a:avLst/>
+          </a:prstGeom>
+          <a:noFill/>
+          <a:ln/>
+        </p:spPr>
+        <p:txBody>
+          <a:bodyPr wrap="square" lIns="0" tIns="0" rIns="0" bIns="0" rtlCol="0" anchor="t"/>
+          <a:lstStyle/>
+          <a:p>
+            <a:pPr indent="0" marL="0">
+              <a:buNone/>
+            </a:pPr>
+            <a:r>
+              <a:rPr lang="en-US" sz="1250" b="1" dirty="0">
+                <a:solidFill>
+                  <a:srgbClr val="1E8E5A"/>
+                </a:solidFill>
+                <a:latin typeface="Calibri" pitchFamily="34" charset="0"/>
+                <a:ea typeface="Calibri" pitchFamily="34" charset="-122"/>
+                <a:cs typeface="Calibri" pitchFamily="34" charset="-120"/>
+              </a:rPr>
+              <a:t>✓  </a:t>
+            </a:r>
+            <a:pPr indent="0" marL="0">
+              <a:spcAft>
+                <a:spcPts val="1100"/>
+              </a:spcAft>
+              <a:buNone/>
+            </a:pPr>
+            <a:r>
+              <a:rPr lang="en-US" sz="1250" dirty="0">
+                <a:solidFill>
+                  <a:srgbClr val="1C2536"/>
+                </a:solidFill>
+                <a:latin typeface="Calibri" pitchFamily="34" charset="0"/>
+                <a:ea typeface="Calibri" pitchFamily="34" charset="-122"/>
+                <a:cs typeface="Calibri" pitchFamily="34" charset="-120"/>
+              </a:rPr>
+              <a:t>Membership lifecycle — plans, freeze, transfer, terminate</a:t>
+            </a:r>
+            <a:endParaRPr lang="en-US" sz="1250" dirty="0"/>
+          </a:p>
+          <a:p>
+            <a:pPr indent="0" marL="0">
+              <a:buNone/>
+            </a:pPr>
+            <a:r>
+              <a:rPr lang="en-US" sz="1250" b="1" dirty="0">
+                <a:solidFill>
+                  <a:srgbClr val="1E8E5A"/>
+                </a:solidFill>
+                <a:latin typeface="Calibri" pitchFamily="34" charset="0"/>
+                <a:ea typeface="Calibri" pitchFamily="34" charset="-122"/>
+                <a:cs typeface="Calibri" pitchFamily="34" charset="-120"/>
+              </a:rPr>
+              <a:t>✓  </a:t>
+            </a:r>
+            <a:pPr indent="0" marL="0">
+              <a:spcAft>
+                <a:spcPts val="1100"/>
+              </a:spcAft>
+              <a:buNone/>
+            </a:pPr>
+            <a:r>
+              <a:rPr lang="en-US" sz="1250" dirty="0">
+                <a:solidFill>
+                  <a:srgbClr val="1C2536"/>
+                </a:solidFill>
+                <a:latin typeface="Calibri" pitchFamily="34" charset="0"/>
+                <a:ea typeface="Calibri" pitchFamily="34" charset="-122"/>
+                <a:cs typeface="Calibri" pitchFamily="34" charset="-120"/>
+              </a:rPr>
+              <a:t>Renewals — Due &amp; Lapsed, before anyone lapses unnoticed</a:t>
+            </a:r>
+            <a:endParaRPr lang="en-US" sz="1250" dirty="0"/>
+          </a:p>
+          <a:p>
+            <a:pPr indent="0" marL="0">
+              <a:buNone/>
+            </a:pPr>
+            <a:r>
+              <a:rPr lang="en-US" sz="1250" b="1" dirty="0">
+                <a:solidFill>
+                  <a:srgbClr val="1E8E5A"/>
+                </a:solidFill>
+                <a:latin typeface="Calibri" pitchFamily="34" charset="0"/>
+                <a:ea typeface="Calibri" pitchFamily="34" charset="-122"/>
+                <a:cs typeface="Calibri" pitchFamily="34" charset="-120"/>
+              </a:rPr>
+              <a:t>✓  </a:t>
+            </a:r>
+            <a:pPr indent="0" marL="0">
+              <a:spcAft>
+                <a:spcPts val="1100"/>
+              </a:spcAft>
+              <a:buNone/>
+            </a:pPr>
+            <a:r>
+              <a:rPr lang="en-US" sz="1250" dirty="0">
+                <a:solidFill>
+                  <a:srgbClr val="1C2536"/>
+                </a:solidFill>
+                <a:latin typeface="Calibri" pitchFamily="34" charset="0"/>
+                <a:ea typeface="Calibri" pitchFamily="34" charset="-122"/>
+                <a:cs typeface="Calibri" pitchFamily="34" charset="-120"/>
+              </a:rPr>
+              <a:t>GST invoicing — sequential numbers, a Discounts tab</a:t>
+            </a:r>
+            <a:endParaRPr lang="en-US" sz="1250" dirty="0"/>
+          </a:p>
+          <a:p>
+            <a:pPr indent="0" marL="0">
+              <a:buNone/>
+            </a:pPr>
+            <a:r>
+              <a:rPr lang="en-US" sz="1250" b="1" dirty="0">
+                <a:solidFill>
+                  <a:srgbClr val="1E8E5A"/>
+                </a:solidFill>
+                <a:latin typeface="Calibri" pitchFamily="34" charset="0"/>
+                <a:ea typeface="Calibri" pitchFamily="34" charset="-122"/>
+                <a:cs typeface="Calibri" pitchFamily="34" charset="-120"/>
+              </a:rPr>
+              <a:t>✓  </a:t>
+            </a:r>
+            <a:pPr indent="0" marL="0">
+              <a:spcAft>
+                <a:spcPts val="1100"/>
+              </a:spcAft>
+              <a:buNone/>
+            </a:pPr>
+            <a:r>
+              <a:rPr lang="en-US" sz="1250" dirty="0">
+                <a:solidFill>
+                  <a:srgbClr val="1C2536"/>
+                </a:solidFill>
+                <a:latin typeface="Calibri" pitchFamily="34" charset="0"/>
+                <a:ea typeface="Calibri" pitchFamily="34" charset="-122"/>
+                <a:cs typeface="Calibri" pitchFamily="34" charset="-120"/>
+              </a:rPr>
+              <a:t>Payments &amp; Collections — worst-first, not oldest-first</a:t>
+            </a:r>
+            <a:endParaRPr lang="en-US" sz="1250" dirty="0"/>
+          </a:p>
+          <a:p>
+            <a:pPr indent="0" marL="0">
+              <a:buNone/>
+            </a:pPr>
+            <a:r>
+              <a:rPr lang="en-US" sz="1250" b="1" dirty="0">
+                <a:solidFill>
+                  <a:srgbClr val="1E8E5A"/>
+                </a:solidFill>
+                <a:latin typeface="Calibri" pitchFamily="34" charset="0"/>
+                <a:ea typeface="Calibri" pitchFamily="34" charset="-122"/>
+                <a:cs typeface="Calibri" pitchFamily="34" charset="-120"/>
+              </a:rPr>
+              <a:t>✓  </a:t>
+            </a:r>
+            <a:pPr indent="0" marL="0">
+              <a:spcAft>
+                <a:spcPts val="1100"/>
+              </a:spcAft>
+              <a:buNone/>
+            </a:pPr>
+            <a:r>
+              <a:rPr lang="en-US" sz="1250" dirty="0">
+                <a:solidFill>
+                  <a:srgbClr val="1C2536"/>
+                </a:solidFill>
+                <a:latin typeface="Calibri" pitchFamily="34" charset="0"/>
+                <a:ea typeface="Calibri" pitchFamily="34" charset="-122"/>
+                <a:cs typeface="Calibri" pitchFamily="34" charset="-120"/>
+              </a:rPr>
+              <a:t>Money Leaks — audits value given away, not just what's owed</a:t>
+            </a:r>
+            <a:endParaRPr lang="en-US" sz="1250" dirty="0"/>
+          </a:p>
+          <a:p>
+            <a:pPr indent="0" marL="0">
+              <a:buNone/>
+            </a:pPr>
+            <a:r>
+              <a:rPr lang="en-US" sz="1250" b="1" dirty="0">
+                <a:solidFill>
+                  <a:srgbClr val="1E8E5A"/>
+                </a:solidFill>
+                <a:latin typeface="Calibri" pitchFamily="34" charset="0"/>
+                <a:ea typeface="Calibri" pitchFamily="34" charset="-122"/>
+                <a:cs typeface="Calibri" pitchFamily="34" charset="-120"/>
+              </a:rPr>
+              <a:t>✓  </a:t>
+            </a:r>
+            <a:pPr indent="0" marL="0">
+              <a:spcAft>
+                <a:spcPts val="1100"/>
+              </a:spcAft>
+              <a:buNone/>
+            </a:pPr>
+            <a:r>
+              <a:rPr lang="en-US" sz="1250" dirty="0">
+                <a:solidFill>
+                  <a:srgbClr val="1C2536"/>
+                </a:solidFill>
+                <a:latin typeface="Calibri" pitchFamily="34" charset="0"/>
+                <a:ea typeface="Calibri" pitchFamily="34" charset="-122"/>
+                <a:cs typeface="Calibri" pitchFamily="34" charset="-120"/>
+              </a:rPr>
+              <a:t>Digital Wallet — balance, top-up, spend</a:t>
+            </a:r>
+            <a:endParaRPr lang="en-US" sz="1250" dirty="0"/>
+          </a:p>
+          <a:p>
+            <a:pPr indent="0" marL="0">
+              <a:buNone/>
+            </a:pPr>
+            <a:r>
+              <a:rPr lang="en-US" sz="1250" b="1" dirty="0">
+                <a:solidFill>
+                  <a:srgbClr val="1E8E5A"/>
+                </a:solidFill>
+                <a:latin typeface="Calibri" pitchFamily="34" charset="0"/>
+                <a:ea typeface="Calibri" pitchFamily="34" charset="-122"/>
+                <a:cs typeface="Calibri" pitchFamily="34" charset="-120"/>
+              </a:rPr>
+              <a:t>✓  </a:t>
+            </a:r>
+            <a:pPr indent="0" marL="0">
+              <a:spcAft>
+                <a:spcPts val="1100"/>
+              </a:spcAft>
+              <a:buNone/>
+            </a:pPr>
+            <a:r>
+              <a:rPr lang="en-US" sz="1250" dirty="0">
+                <a:solidFill>
+                  <a:srgbClr val="1C2536"/>
+                </a:solidFill>
+                <a:latin typeface="Calibri" pitchFamily="34" charset="0"/>
+                <a:ea typeface="Calibri" pitchFamily="34" charset="-122"/>
+                <a:cs typeface="Calibri" pitchFamily="34" charset="-120"/>
+              </a:rPr>
+              <a:t>Shop (POS) — Sell, Restock, Stock and Sales, four tabs</a:t>
+            </a:r>
+            <a:endParaRPr lang="en-US" sz="1250" dirty="0"/>
+          </a:p>
+          <a:p>
+            <a:pPr indent="0" marL="0">
+              <a:buNone/>
+            </a:pPr>
+            <a:r>
+              <a:rPr lang="en-US" sz="1250" b="1" dirty="0">
+                <a:solidFill>
+                  <a:srgbClr val="1E8E5A"/>
+                </a:solidFill>
+                <a:latin typeface="Calibri" pitchFamily="34" charset="0"/>
+                <a:ea typeface="Calibri" pitchFamily="34" charset="-122"/>
+                <a:cs typeface="Calibri" pitchFamily="34" charset="-120"/>
+              </a:rPr>
+              <a:t>✓  </a:t>
+            </a:r>
+            <a:pPr indent="0" marL="0">
+              <a:spcAft>
+                <a:spcPts val="1100"/>
+              </a:spcAft>
+              <a:buNone/>
+            </a:pPr>
+            <a:r>
+              <a:rPr lang="en-US" sz="1250" dirty="0">
+                <a:solidFill>
+                  <a:srgbClr val="1C2536"/>
+                </a:solidFill>
+                <a:latin typeface="Calibri" pitchFamily="34" charset="0"/>
+                <a:ea typeface="Calibri" pitchFamily="34" charset="-122"/>
+                <a:cs typeface="Calibri" pitchFamily="34" charset="-120"/>
+              </a:rPr>
+              <a:t>Stock analytics — reorder now / dead / overstocked, by product</a:t>
+            </a:r>
+            <a:endParaRPr lang="en-US" sz="1250" dirty="0"/>
+          </a:p>
+          <a:p>
+            <a:pPr indent="0" marL="0">
+              <a:buNone/>
+            </a:pPr>
+            <a:r>
+              <a:rPr lang="en-US" sz="1250" b="1" dirty="0">
+                <a:solidFill>
+                  <a:srgbClr val="1E8E5A"/>
+                </a:solidFill>
+                <a:latin typeface="Calibri" pitchFamily="34" charset="0"/>
+                <a:ea typeface="Calibri" pitchFamily="34" charset="-122"/>
+                <a:cs typeface="Calibri" pitchFamily="34" charset="-120"/>
+              </a:rPr>
+              <a:t>✓  </a:t>
+            </a:r>
+            <a:pPr indent="0" marL="0">
+              <a:spcAft>
+                <a:spcPts val="1100"/>
+              </a:spcAft>
+              <a:buNone/>
+            </a:pPr>
+            <a:r>
+              <a:rPr lang="en-US" sz="1250" dirty="0">
+                <a:solidFill>
+                  <a:srgbClr val="1C2536"/>
+                </a:solidFill>
+                <a:latin typeface="Calibri" pitchFamily="34" charset="0"/>
+                <a:ea typeface="Calibri" pitchFamily="34" charset="-122"/>
+                <a:cs typeface="Calibri" pitchFamily="34" charset="-120"/>
+              </a:rPr>
+              <a:t>Attendance &amp; check-in</a:t>
+            </a:r>
+            <a:endParaRPr lang="en-US" sz="1250" dirty="0"/>
+          </a:p>
+          <a:p>
+            <a:pPr indent="0" marL="0">
+              <a:buNone/>
+            </a:pPr>
+            <a:r>
+              <a:rPr lang="en-US" sz="1250" b="1" dirty="0">
+                <a:solidFill>
+                  <a:srgbClr val="1E8E5A"/>
+                </a:solidFill>
+                <a:latin typeface="Calibri" pitchFamily="34" charset="0"/>
+                <a:ea typeface="Calibri" pitchFamily="34" charset="-122"/>
+                <a:cs typeface="Calibri" pitchFamily="34" charset="-120"/>
+              </a:rPr>
+              <a:t>✓  </a:t>
+            </a:r>
+            <a:pPr indent="0" marL="0">
+              <a:spcAft>
+                <a:spcPts val="1100"/>
+              </a:spcAft>
+              <a:buNone/>
+            </a:pPr>
+            <a:r>
+              <a:rPr lang="en-US" sz="1250" dirty="0">
+                <a:solidFill>
+                  <a:srgbClr val="1C2536"/>
+                </a:solidFill>
+                <a:latin typeface="Calibri" pitchFamily="34" charset="0"/>
+                <a:ea typeface="Calibri" pitchFamily="34" charset="-122"/>
+                <a:cs typeface="Calibri" pitchFamily="34" charset="-120"/>
+              </a:rPr>
+              <a:t>Classes &amp; schedule</a:t>
+            </a:r>
+            <a:endParaRPr lang="en-US" sz="1250" dirty="0"/>
+          </a:p>
+          <a:p>
+            <a:pPr indent="0" marL="0">
+              <a:buNone/>
+            </a:pPr>
+            <a:r>
+              <a:rPr lang="en-US" sz="1250" b="1" dirty="0">
+                <a:solidFill>
+                  <a:srgbClr val="1E8E5A"/>
+                </a:solidFill>
+                <a:latin typeface="Calibri" pitchFamily="34" charset="0"/>
+                <a:ea typeface="Calibri" pitchFamily="34" charset="-122"/>
+                <a:cs typeface="Calibri" pitchFamily="34" charset="-120"/>
+              </a:rPr>
+              <a:t>✓  </a:t>
+            </a:r>
+            <a:pPr indent="0" marL="0">
+              <a:spcAft>
+                <a:spcPts val="1100"/>
+              </a:spcAft>
+              <a:buNone/>
+            </a:pPr>
+            <a:r>
+              <a:rPr lang="en-US" sz="1250" dirty="0">
+                <a:solidFill>
+                  <a:srgbClr val="1C2536"/>
+                </a:solidFill>
+                <a:latin typeface="Calibri" pitchFamily="34" charset="0"/>
+                <a:ea typeface="Calibri" pitchFamily="34" charset="-122"/>
+                <a:cs typeface="Calibri" pitchFamily="34" charset="-120"/>
+              </a:rPr>
+              <a:t>Personal Training — packages and appointments</a:t>
+            </a:r>
+            <a:endParaRPr lang="en-US" sz="1250" dirty="0"/>
+          </a:p>
+          <a:p>
+            <a:pPr indent="0" marL="0">
+              <a:buNone/>
+            </a:pPr>
+            <a:r>
+              <a:rPr lang="en-US" sz="1250" b="1" dirty="0">
+                <a:solidFill>
+                  <a:srgbClr val="1E8E5A"/>
+                </a:solidFill>
+                <a:latin typeface="Calibri" pitchFamily="34" charset="0"/>
+                <a:ea typeface="Calibri" pitchFamily="34" charset="-122"/>
+                <a:cs typeface="Calibri" pitchFamily="34" charset="-120"/>
+              </a:rPr>
+              <a:t>✓  </a:t>
+            </a:r>
+            <a:pPr indent="0" marL="0">
+              <a:spcAft>
+                <a:spcPts val="1100"/>
+              </a:spcAft>
+              <a:buNone/>
+            </a:pPr>
+            <a:r>
+              <a:rPr lang="en-US" sz="1250" dirty="0">
+                <a:solidFill>
+                  <a:srgbClr val="1C2536"/>
+                </a:solidFill>
+                <a:latin typeface="Calibri" pitchFamily="34" charset="0"/>
+                <a:ea typeface="Calibri" pitchFamily="34" charset="-122"/>
+                <a:cs typeface="Calibri" pitchFamily="34" charset="-120"/>
+              </a:rPr>
+              <a:t>PT Feedback, Reports &amp; Recognition</a:t>
+            </a:r>
+            <a:endParaRPr lang="en-US" sz="1250" dirty="0"/>
+          </a:p>
+        </p:txBody>
+      </p:sp>
+      <p:sp>
+        <p:nvSpPr>
+          <p:cNvPr id="8" name="Text 5"/>
+          <p:cNvSpPr txBox="1"/>
+          <p:nvPr/>
+        </p:nvSpPr>
+        <p:spPr>
+          <a:xfrm>
+            <a:off x="6324448" y="1874520"/>
+            <a:ext cx="5318608" cy="4434840"/>
+          </a:xfrm>
+          <a:prstGeom prst="rect">
+            <a:avLst/>
+          </a:prstGeom>
+          <a:noFill/>
+          <a:ln/>
+        </p:spPr>
+        <p:txBody>
+          <a:bodyPr wrap="square" lIns="0" tIns="0" rIns="0" bIns="0" rtlCol="0" anchor="t"/>
+          <a:lstStyle/>
+          <a:p>
+            <a:pPr indent="0" marL="0">
+              <a:buNone/>
+            </a:pPr>
+            <a:r>
+              <a:rPr lang="en-US" sz="1250" b="1" dirty="0">
+                <a:solidFill>
+                  <a:srgbClr val="1E8E5A"/>
+                </a:solidFill>
+                <a:latin typeface="Calibri" pitchFamily="34" charset="0"/>
+                <a:ea typeface="Calibri" pitchFamily="34" charset="-122"/>
+                <a:cs typeface="Calibri" pitchFamily="34" charset="-120"/>
+              </a:rPr>
+              <a:t>✓  </a:t>
+            </a:r>
+            <a:pPr indent="0" marL="0">
+              <a:spcAft>
+                <a:spcPts val="1100"/>
+              </a:spcAft>
+              <a:buNone/>
+            </a:pPr>
+            <a:r>
+              <a:rPr lang="en-US" sz="1250" dirty="0">
+                <a:solidFill>
+                  <a:srgbClr val="1C2536"/>
+                </a:solidFill>
+                <a:latin typeface="Calibri" pitchFamily="34" charset="0"/>
+                <a:ea typeface="Calibri" pitchFamily="34" charset="-122"/>
+                <a:cs typeface="Calibri" pitchFamily="34" charset="-120"/>
+              </a:rPr>
+              <a:t>Trainer payouts — computed, never silent</a:t>
+            </a:r>
+            <a:endParaRPr lang="en-US" sz="1250" dirty="0"/>
+          </a:p>
+          <a:p>
+            <a:pPr indent="0" marL="0">
+              <a:buNone/>
+            </a:pPr>
+            <a:r>
+              <a:rPr lang="en-US" sz="1250" b="1" dirty="0">
+                <a:solidFill>
+                  <a:srgbClr val="1E8E5A"/>
+                </a:solidFill>
+                <a:latin typeface="Calibri" pitchFamily="34" charset="0"/>
+                <a:ea typeface="Calibri" pitchFamily="34" charset="-122"/>
+                <a:cs typeface="Calibri" pitchFamily="34" charset="-120"/>
+              </a:rPr>
+              <a:t>✓  </a:t>
+            </a:r>
+            <a:pPr indent="0" marL="0">
+              <a:spcAft>
+                <a:spcPts val="1100"/>
+              </a:spcAft>
+              <a:buNone/>
+            </a:pPr>
+            <a:r>
+              <a:rPr lang="en-US" sz="1250" dirty="0">
+                <a:solidFill>
+                  <a:srgbClr val="1C2536"/>
+                </a:solidFill>
+                <a:latin typeface="Calibri" pitchFamily="34" charset="0"/>
+                <a:ea typeface="Calibri" pitchFamily="34" charset="-122"/>
+                <a:cs typeface="Calibri" pitchFamily="34" charset="-120"/>
+              </a:rPr>
+              <a:t>Leads CRM — five-stage pipeline, a default next step for each</a:t>
+            </a:r>
+            <a:endParaRPr lang="en-US" sz="1250" dirty="0"/>
+          </a:p>
+          <a:p>
+            <a:pPr indent="0" marL="0">
+              <a:buNone/>
+            </a:pPr>
+            <a:r>
+              <a:rPr lang="en-US" sz="1250" b="1" dirty="0">
+                <a:solidFill>
+                  <a:srgbClr val="1E8E5A"/>
+                </a:solidFill>
+                <a:latin typeface="Calibri" pitchFamily="34" charset="0"/>
+                <a:ea typeface="Calibri" pitchFamily="34" charset="-122"/>
+                <a:cs typeface="Calibri" pitchFamily="34" charset="-120"/>
+              </a:rPr>
+              <a:t>✓  </a:t>
+            </a:r>
+            <a:pPr indent="0" marL="0">
+              <a:spcAft>
+                <a:spcPts val="1100"/>
+              </a:spcAft>
+              <a:buNone/>
+            </a:pPr>
+            <a:r>
+              <a:rPr lang="en-US" sz="1250" dirty="0">
+                <a:solidFill>
+                  <a:srgbClr val="1C2536"/>
+                </a:solidFill>
+                <a:latin typeface="Calibri" pitchFamily="34" charset="0"/>
+                <a:ea typeface="Calibri" pitchFamily="34" charset="-122"/>
+                <a:cs typeface="Calibri" pitchFamily="34" charset="-120"/>
+              </a:rPr>
+              <a:t>Lead workflow &amp; follow-ups — nothing goes quiet unnoticed</a:t>
+            </a:r>
+            <a:endParaRPr lang="en-US" sz="1250" dirty="0"/>
+          </a:p>
+          <a:p>
+            <a:pPr indent="0" marL="0">
+              <a:buNone/>
+            </a:pPr>
+            <a:r>
+              <a:rPr lang="en-US" sz="1250" b="1" dirty="0">
+                <a:solidFill>
+                  <a:srgbClr val="1E8E5A"/>
+                </a:solidFill>
+                <a:latin typeface="Calibri" pitchFamily="34" charset="0"/>
+                <a:ea typeface="Calibri" pitchFamily="34" charset="-122"/>
+                <a:cs typeface="Calibri" pitchFamily="34" charset="-120"/>
+              </a:rPr>
+              <a:t>✓  </a:t>
+            </a:r>
+            <a:pPr indent="0" marL="0">
+              <a:spcAft>
+                <a:spcPts val="1100"/>
+              </a:spcAft>
+              <a:buNone/>
+            </a:pPr>
+            <a:r>
+              <a:rPr lang="en-US" sz="1250" dirty="0">
+                <a:solidFill>
+                  <a:srgbClr val="1C2536"/>
+                </a:solidFill>
+                <a:latin typeface="Calibri" pitchFamily="34" charset="0"/>
+                <a:ea typeface="Calibri" pitchFamily="34" charset="-122"/>
+                <a:cs typeface="Calibri" pitchFamily="34" charset="-120"/>
+              </a:rPr>
+              <a:t>Visitors — walk-ins, trials, tours</a:t>
+            </a:r>
+            <a:endParaRPr lang="en-US" sz="1250" dirty="0"/>
+          </a:p>
+          <a:p>
+            <a:pPr indent="0" marL="0">
+              <a:buNone/>
+            </a:pPr>
+            <a:r>
+              <a:rPr lang="en-US" sz="1250" b="1" dirty="0">
+                <a:solidFill>
+                  <a:srgbClr val="1E8E5A"/>
+                </a:solidFill>
+                <a:latin typeface="Calibri" pitchFamily="34" charset="0"/>
+                <a:ea typeface="Calibri" pitchFamily="34" charset="-122"/>
+                <a:cs typeface="Calibri" pitchFamily="34" charset="-120"/>
+              </a:rPr>
+              <a:t>✓  </a:t>
+            </a:r>
+            <a:pPr indent="0" marL="0">
+              <a:spcAft>
+                <a:spcPts val="1100"/>
+              </a:spcAft>
+              <a:buNone/>
+            </a:pPr>
+            <a:r>
+              <a:rPr lang="en-US" sz="1250" dirty="0">
+                <a:solidFill>
+                  <a:srgbClr val="1C2536"/>
+                </a:solidFill>
+                <a:latin typeface="Calibri" pitchFamily="34" charset="0"/>
+                <a:ea typeface="Calibri" pitchFamily="34" charset="-122"/>
+                <a:cs typeface="Calibri" pitchFamily="34" charset="-120"/>
+              </a:rPr>
+              <a:t>Referral tracking — who brought whom, and whether it converted</a:t>
+            </a:r>
+            <a:endParaRPr lang="en-US" sz="1250" dirty="0"/>
+          </a:p>
+          <a:p>
+            <a:pPr indent="0" marL="0">
+              <a:buNone/>
+            </a:pPr>
+            <a:r>
+              <a:rPr lang="en-US" sz="1250" b="1" dirty="0">
+                <a:solidFill>
+                  <a:srgbClr val="1E8E5A"/>
+                </a:solidFill>
+                <a:latin typeface="Calibri" pitchFamily="34" charset="0"/>
+                <a:ea typeface="Calibri" pitchFamily="34" charset="-122"/>
+                <a:cs typeface="Calibri" pitchFamily="34" charset="-120"/>
+              </a:rPr>
+              <a:t>✓  </a:t>
+            </a:r>
+            <a:pPr indent="0" marL="0">
+              <a:spcAft>
+                <a:spcPts val="1100"/>
+              </a:spcAft>
+              <a:buNone/>
+            </a:pPr>
+            <a:r>
+              <a:rPr lang="en-US" sz="1250" dirty="0">
+                <a:solidFill>
+                  <a:srgbClr val="1C2536"/>
+                </a:solidFill>
+                <a:latin typeface="Calibri" pitchFamily="34" charset="0"/>
+                <a:ea typeface="Calibri" pitchFamily="34" charset="-122"/>
+                <a:cs typeface="Calibri" pitchFamily="34" charset="-120"/>
+              </a:rPr>
+              <a:t>At Risk — real visits behind every flag, never a guess</a:t>
+            </a:r>
+            <a:endParaRPr lang="en-US" sz="1250" dirty="0"/>
+          </a:p>
+          <a:p>
+            <a:pPr indent="0" marL="0">
+              <a:buNone/>
+            </a:pPr>
+            <a:r>
+              <a:rPr lang="en-US" sz="1250" b="1" dirty="0">
+                <a:solidFill>
+                  <a:srgbClr val="1E8E5A"/>
+                </a:solidFill>
+                <a:latin typeface="Calibri" pitchFamily="34" charset="0"/>
+                <a:ea typeface="Calibri" pitchFamily="34" charset="-122"/>
+                <a:cs typeface="Calibri" pitchFamily="34" charset="-120"/>
+              </a:rPr>
+              <a:t>✓  </a:t>
+            </a:r>
+            <a:pPr indent="0" marL="0">
+              <a:spcAft>
+                <a:spcPts val="1100"/>
+              </a:spcAft>
+              <a:buNone/>
+            </a:pPr>
+            <a:r>
+              <a:rPr lang="en-US" sz="1250" dirty="0">
+                <a:solidFill>
+                  <a:srgbClr val="1C2536"/>
+                </a:solidFill>
+                <a:latin typeface="Calibri" pitchFamily="34" charset="0"/>
+                <a:ea typeface="Calibri" pitchFamily="34" charset="-122"/>
+                <a:cs typeface="Calibri" pitchFamily="34" charset="-120"/>
+              </a:rPr>
+              <a:t>Analytics — Business, Leads, Retention and Staff in one section</a:t>
+            </a:r>
+            <a:endParaRPr lang="en-US" sz="1250" dirty="0"/>
+          </a:p>
+          <a:p>
+            <a:pPr indent="0" marL="0">
+              <a:buNone/>
+            </a:pPr>
+            <a:r>
+              <a:rPr lang="en-US" sz="1250" b="1" dirty="0">
+                <a:solidFill>
+                  <a:srgbClr val="1E8E5A"/>
+                </a:solidFill>
+                <a:latin typeface="Calibri" pitchFamily="34" charset="0"/>
+                <a:ea typeface="Calibri" pitchFamily="34" charset="-122"/>
+                <a:cs typeface="Calibri" pitchFamily="34" charset="-120"/>
+              </a:rPr>
+              <a:t>✓  </a:t>
+            </a:r>
+            <a:pPr indent="0" marL="0">
+              <a:spcAft>
+                <a:spcPts val="1100"/>
+              </a:spcAft>
+              <a:buNone/>
+            </a:pPr>
+            <a:r>
+              <a:rPr lang="en-US" sz="1250" dirty="0">
+                <a:solidFill>
+                  <a:srgbClr val="1C2536"/>
+                </a:solidFill>
+                <a:latin typeface="Calibri" pitchFamily="34" charset="0"/>
+                <a:ea typeface="Calibri" pitchFamily="34" charset="-122"/>
+                <a:cs typeface="Calibri" pitchFamily="34" charset="-120"/>
+              </a:rPr>
+              <a:t>Staff Work — a record of the day, never a leaderboard</a:t>
+            </a:r>
+            <a:endParaRPr lang="en-US" sz="1250" dirty="0"/>
+          </a:p>
+          <a:p>
+            <a:pPr indent="0" marL="0">
+              <a:buNone/>
+            </a:pPr>
+            <a:r>
+              <a:rPr lang="en-US" sz="1250" b="1" dirty="0">
+                <a:solidFill>
+                  <a:srgbClr val="1E8E5A"/>
+                </a:solidFill>
+                <a:latin typeface="Calibri" pitchFamily="34" charset="0"/>
+                <a:ea typeface="Calibri" pitchFamily="34" charset="-122"/>
+                <a:cs typeface="Calibri" pitchFamily="34" charset="-120"/>
+              </a:rPr>
+              <a:t>✓  </a:t>
+            </a:r>
+            <a:pPr indent="0" marL="0">
+              <a:spcAft>
+                <a:spcPts val="1100"/>
+              </a:spcAft>
+              <a:buNone/>
+            </a:pPr>
+            <a:r>
+              <a:rPr lang="en-US" sz="1250" dirty="0">
+                <a:solidFill>
+                  <a:srgbClr val="1C2536"/>
+                </a:solidFill>
+                <a:latin typeface="Calibri" pitchFamily="34" charset="0"/>
+                <a:ea typeface="Calibri" pitchFamily="34" charset="-122"/>
+                <a:cs typeface="Calibri" pitchFamily="34" charset="-120"/>
+              </a:rPr>
+              <a:t>Staff accounts — role-based login, deactivate rather than delete</a:t>
+            </a:r>
+            <a:endParaRPr lang="en-US" sz="1250" dirty="0"/>
+          </a:p>
+          <a:p>
+            <a:pPr indent="0" marL="0">
+              <a:buNone/>
+            </a:pPr>
+            <a:r>
+              <a:rPr lang="en-US" sz="1250" b="1" dirty="0">
+                <a:solidFill>
+                  <a:srgbClr val="1E8E5A"/>
+                </a:solidFill>
+                <a:latin typeface="Calibri" pitchFamily="34" charset="0"/>
+                <a:ea typeface="Calibri" pitchFamily="34" charset="-122"/>
+                <a:cs typeface="Calibri" pitchFamily="34" charset="-120"/>
+              </a:rPr>
+              <a:t>✓  </a:t>
+            </a:r>
+            <a:pPr indent="0" marL="0">
+              <a:spcAft>
+                <a:spcPts val="1100"/>
+              </a:spcAft>
+              <a:buNone/>
+            </a:pPr>
+            <a:r>
+              <a:rPr lang="en-US" sz="1250" dirty="0">
+                <a:solidFill>
+                  <a:srgbClr val="1C2536"/>
+                </a:solidFill>
+                <a:latin typeface="Calibri" pitchFamily="34" charset="0"/>
+                <a:ea typeface="Calibri" pitchFamily="34" charset="-122"/>
+                <a:cs typeface="Calibri" pitchFamily="34" charset="-120"/>
+              </a:rPr>
+              <a:t>Multi-branch — chain overview, targets, stock transfer</a:t>
+            </a:r>
+            <a:endParaRPr lang="en-US" sz="1250" dirty="0"/>
+          </a:p>
+          <a:p>
+            <a:pPr indent="0" marL="0">
+              <a:buNone/>
+            </a:pPr>
+            <a:r>
+              <a:rPr lang="en-US" sz="1250" b="1" dirty="0">
+                <a:solidFill>
+                  <a:srgbClr val="1E8E5A"/>
+                </a:solidFill>
+                <a:latin typeface="Calibri" pitchFamily="34" charset="0"/>
+                <a:ea typeface="Calibri" pitchFamily="34" charset="-122"/>
+                <a:cs typeface="Calibri" pitchFamily="34" charset="-120"/>
+              </a:rPr>
+              <a:t>✓  </a:t>
+            </a:r>
+            <a:pPr indent="0" marL="0">
+              <a:spcAft>
+                <a:spcPts val="1100"/>
+              </a:spcAft>
+              <a:buNone/>
+            </a:pPr>
+            <a:r>
+              <a:rPr lang="en-US" sz="1250" dirty="0">
+                <a:solidFill>
+                  <a:srgbClr val="1C2536"/>
+                </a:solidFill>
+                <a:latin typeface="Calibri" pitchFamily="34" charset="0"/>
+                <a:ea typeface="Calibri" pitchFamily="34" charset="-122"/>
+                <a:cs typeface="Calibri" pitchFamily="34" charset="-120"/>
+              </a:rPr>
+              <a:t>Data import — bring in an old member list safely, in two stages</a:t>
+            </a:r>
+            <a:endParaRPr lang="en-US" sz="1250" dirty="0"/>
+          </a:p>
+          <a:p>
+            <a:pPr indent="0" marL="0">
+              <a:buNone/>
+            </a:pPr>
+            <a:r>
+              <a:rPr lang="en-US" sz="1250" b="1" dirty="0">
+                <a:solidFill>
+                  <a:srgbClr val="1E8E5A"/>
+                </a:solidFill>
+                <a:latin typeface="Calibri" pitchFamily="34" charset="0"/>
+                <a:ea typeface="Calibri" pitchFamily="34" charset="-122"/>
+                <a:cs typeface="Calibri" pitchFamily="34" charset="-120"/>
+              </a:rPr>
+              <a:t>✓  </a:t>
+            </a:r>
+            <a:pPr indent="0" marL="0">
+              <a:spcAft>
+                <a:spcPts val="1100"/>
+              </a:spcAft>
+              <a:buNone/>
+            </a:pPr>
+            <a:r>
+              <a:rPr lang="en-US" sz="1250" dirty="0">
+                <a:solidFill>
+                  <a:srgbClr val="1C2536"/>
+                </a:solidFill>
+                <a:latin typeface="Calibri" pitchFamily="34" charset="0"/>
+                <a:ea typeface="Calibri" pitchFamily="34" charset="-122"/>
+                <a:cs typeface="Calibri" pitchFamily="34" charset="-120"/>
+              </a:rPr>
+              <a:t>Every membership change recorded — who did it, and when</a:t>
+            </a:r>
+            <a:endParaRPr lang="en-US" sz="1250" dirty="0"/>
+          </a:p>
+        </p:txBody>
+      </p:sp>
+      <p:sp>
+        <p:nvSpPr>
+          <p:cNvPr id="9" name="Shape 6"/>
+          <p:cNvSpPr/>
+          <p:nvPr/>
+        </p:nvSpPr>
+        <p:spPr>
+          <a:xfrm>
+            <a:off x="6095848" y="1874520"/>
+            <a:ext cx="0" cy="4389120"/>
+          </a:xfrm>
+          <a:prstGeom prst="line">
+            <a:avLst/>
+          </a:prstGeom>
+          <a:noFill/>
+          <a:ln w="12700">
+            <a:solidFill>
+              <a:srgbClr val="E2E6ED"/>
+            </a:solidFill>
+            <a:prstDash val="solid"/>
+          </a:ln>
+        </p:spPr>
+      </p:sp>
+      <p:sp>
+        <p:nvSpPr>
+          <p:cNvPr id="10" name="Text 7"/>
+          <p:cNvSpPr txBox="1"/>
+          <p:nvPr/>
+        </p:nvSpPr>
+        <p:spPr>
+          <a:xfrm>
+            <a:off x="548640" y="6446520"/>
+            <a:ext cx="5486400" cy="274320"/>
+          </a:xfrm>
+          <a:prstGeom prst="rect">
+            <a:avLst/>
+          </a:prstGeom>
+          <a:noFill/>
+          <a:ln/>
+        </p:spPr>
+        <p:txBody>
+          <a:bodyPr wrap="square" lIns="0" tIns="0" rIns="0" bIns="0" rtlCol="0" anchor="ctr"/>
+          <a:lstStyle/>
+          <a:p>
+            <a:pPr indent="0" marL="0">
+              <a:buNone/>
+            </a:pPr>
+            <a:r>
+              <a:rPr lang="en-US" sz="900" spc="100" kern="0" dirty="0">
+                <a:solidFill>
+                  <a:srgbClr val="6B7280"/>
+                </a:solidFill>
+                <a:latin typeface="Calibri" pitchFamily="34" charset="0"/>
+                <a:ea typeface="Calibri" pitchFamily="34" charset="-122"/>
+                <a:cs typeface="Calibri" pitchFamily="34" charset="-120"/>
+              </a:rPr>
+              <a:t>ALSO READ</a:t>
+            </a:r>
+            <a:endParaRPr lang="en-US" sz="900" dirty="0"/>
+          </a:p>
+        </p:txBody>
+      </p:sp>
+      <p:sp>
+        <p:nvSpPr>
+          <p:cNvPr id="11" name="Text 8"/>
+          <p:cNvSpPr txBox="1"/>
+          <p:nvPr/>
+        </p:nvSpPr>
+        <p:spPr>
+          <a:xfrm>
+            <a:off x="10728655" y="6446520"/>
+            <a:ext cx="914400" cy="274320"/>
+          </a:xfrm>
+          <a:prstGeom prst="rect">
+            <a:avLst/>
+          </a:prstGeom>
+          <a:noFill/>
+          <a:ln/>
+        </p:spPr>
+        <p:txBody>
+          <a:bodyPr wrap="square" lIns="0" tIns="0" rIns="0" bIns="0" rtlCol="0" anchor="ctr"/>
+          <a:lstStyle/>
+          <a:p>
+            <a:pPr algn="r" indent="0" marL="0">
+              <a:buNone/>
+            </a:pPr>
+            <a:r>
+              <a:rPr lang="en-US" sz="900" dirty="0">
+                <a:solidFill>
+                  <a:srgbClr val="6B7280"/>
+                </a:solidFill>
+                <a:latin typeface="Calibri" pitchFamily="34" charset="0"/>
+                <a:ea typeface="Calibri" pitchFamily="34" charset="-122"/>
+                <a:cs typeface="Calibri" pitchFamily="34" charset="-120"/>
+              </a:rPr>
+              <a:t>32</a:t>
+            </a:r>
+            <a:endParaRPr lang="en-US" sz="900" dirty="0"/>
+          </a:p>
+        </p:txBody>
+      </p:sp>
+    </p:spTree>
+  </p:cSld>
+  <p:clrMapOvr>
+    <a:masterClrMapping/>
+  </p:clrMapOvr>
+</p:sld>
+</file>
+
+<file path=ppt/slides/slide33.xml><?xml version="1.0" encoding="utf-8"?>
+<p:sld xmlns:a="http://schemas.openxmlformats.org/drawingml/2006/main" xmlns:r="http://schemas.openxmlformats.org/officeDocument/2006/relationships" xmlns:p="http://schemas.openxmlformats.org/presentationml/2006/main">
+  <p:cSld name="Slide 33">
+    <p:bg>
+      <p:bgPr>
+        <a:solidFill>
+          <a:srgbClr val="FFFFFF"/>
+        </a:solidFill>
+      </p:bgPr>
+    </p:bg>
+    <p:spTree>
+      <p:nvGrpSpPr>
+        <p:cNvPr id="1" name=""/>
+        <p:cNvGrpSpPr/>
+        <p:nvPr/>
+      </p:nvGrpSpPr>
+      <p:grpSpPr>
+        <a:xfrm>
+          <a:off x="0" y="0"/>
+          <a:ext cx="0" cy="0"/>
+          <a:chOff x="0" y="0"/>
+          <a:chExt cx="0" cy="0"/>
+        </a:xfrm>
+      </p:grpSpPr>
+      <p:sp>
+        <p:nvSpPr>
+          <p:cNvPr id="2" name="Text 0"/>
+          <p:cNvSpPr txBox="1"/>
+          <p:nvPr/>
+        </p:nvSpPr>
+        <p:spPr>
+          <a:xfrm>
+            <a:off x="548640" y="384048"/>
+            <a:ext cx="9144000" cy="274320"/>
+          </a:xfrm>
+          <a:prstGeom prst="rect">
+            <a:avLst/>
+          </a:prstGeom>
+          <a:noFill/>
+          <a:ln/>
+        </p:spPr>
+        <p:txBody>
+          <a:bodyPr wrap="square" lIns="0" tIns="0" rIns="0" bIns="0" rtlCol="0" anchor="ctr"/>
+          <a:lstStyle/>
+          <a:p>
+            <a:pPr indent="0" marL="0">
+              <a:buNone/>
+            </a:pPr>
+            <a:r>
+              <a:rPr lang="en-US" sz="1200" b="1" spc="150" kern="0" dirty="0">
+                <a:solidFill>
+                  <a:srgbClr val="FF5A4E"/>
+                </a:solidFill>
+                <a:latin typeface="Calibri" pitchFamily="34" charset="0"/>
+                <a:ea typeface="Calibri" pitchFamily="34" charset="-122"/>
+                <a:cs typeface="Calibri" pitchFamily="34" charset="-120"/>
+              </a:rPr>
+              <a:t>ALSO READ</a:t>
+            </a:r>
+            <a:endParaRPr lang="en-US" sz="1200" dirty="0"/>
+          </a:p>
+        </p:txBody>
+      </p:sp>
+      <p:sp>
+        <p:nvSpPr>
+          <p:cNvPr id="3" name="Text 1"/>
+          <p:cNvSpPr txBox="1"/>
+          <p:nvPr/>
+        </p:nvSpPr>
+        <p:spPr>
+          <a:xfrm>
+            <a:off x="548640" y="658368"/>
+            <a:ext cx="9875520" cy="594360"/>
+          </a:xfrm>
+          <a:prstGeom prst="rect">
+            <a:avLst/>
+          </a:prstGeom>
+          <a:noFill/>
+          <a:ln/>
+        </p:spPr>
+        <p:txBody>
+          <a:bodyPr wrap="square" lIns="0" tIns="0" rIns="0" bIns="0" rtlCol="0" anchor="ctr"/>
+          <a:lstStyle/>
+          <a:p>
+            <a:pPr indent="0" marL="0">
+              <a:buNone/>
+            </a:pPr>
+            <a:r>
+              <a:rPr lang="en-US" sz="3000" b="1" dirty="0">
+                <a:solidFill>
+                  <a:srgbClr val="12203D"/>
+                </a:solidFill>
+                <a:latin typeface="Cambria" pitchFamily="34" charset="0"/>
+                <a:ea typeface="Cambria" pitchFamily="34" charset="-122"/>
+                <a:cs typeface="Cambria" pitchFamily="34" charset="-120"/>
+              </a:rPr>
+              <a:t>Quick Reference</a:t>
+            </a:r>
+            <a:endParaRPr lang="en-US" sz="3000" dirty="0"/>
+          </a:p>
+        </p:txBody>
+      </p:sp>
+      <p:sp>
+        <p:nvSpPr>
+          <p:cNvPr id="4" name="Text 2"/>
+          <p:cNvSpPr txBox="1"/>
+          <p:nvPr/>
+        </p:nvSpPr>
+        <p:spPr>
+          <a:xfrm>
+            <a:off x="548640" y="1280160"/>
+            <a:ext cx="10515600" cy="457200"/>
+          </a:xfrm>
+          <a:prstGeom prst="rect">
+            <a:avLst/>
+          </a:prstGeom>
+          <a:noFill/>
+          <a:ln/>
+        </p:spPr>
+        <p:txBody>
+          <a:bodyPr wrap="square" lIns="0" tIns="0" rIns="0" bIns="0" rtlCol="0" anchor="ctr"/>
+          <a:lstStyle/>
+          <a:p>
+            <a:pPr indent="0" marL="0">
+              <a:buNone/>
+            </a:pPr>
+            <a:r>
+              <a:rPr lang="en-US" sz="1450" i="1" dirty="0">
+                <a:solidFill>
+                  <a:srgbClr val="6B7280"/>
+                </a:solidFill>
+                <a:latin typeface="Calibri" pitchFamily="34" charset="0"/>
+                <a:ea typeface="Calibri" pitchFamily="34" charset="-122"/>
+                <a:cs typeface="Calibri" pitchFamily="34" charset="-120"/>
+              </a:rPr>
+              <a:t>The fastest way from “I want to…” to the right screen.</a:t>
+            </a:r>
+            <a:endParaRPr lang="en-US" sz="1450" dirty="0"/>
+          </a:p>
+        </p:txBody>
+      </p:sp>
+      <p:sp>
+        <p:nvSpPr>
+          <p:cNvPr id="5" name="Shape 3"/>
+          <p:cNvSpPr/>
+          <p:nvPr/>
+        </p:nvSpPr>
+        <p:spPr>
+          <a:xfrm>
+            <a:off x="10820095" y="457200"/>
+            <a:ext cx="822960" cy="822960"/>
+          </a:xfrm>
+          <a:prstGeom prst="ellipse">
+            <a:avLst/>
+          </a:prstGeom>
+          <a:solidFill>
+            <a:srgbClr val="12203D"/>
+          </a:solidFill>
+          <a:ln/>
+        </p:spPr>
+      </p:sp>
+      <p:pic>
+        <p:nvPicPr>
+          <p:cNvPr id="6" name="Image 0" descr="preencoded.png">    </p:cNvPr>
+          <p:cNvPicPr>
+            <a:picLocks noChangeAspect="1"/>
+          </p:cNvPicPr>
+          <p:nvPr/>
+        </p:nvPicPr>
+        <p:blipFill>
+          <a:blip r:embed="rId1"/>
+          <a:stretch>
+            <a:fillRect/>
+          </a:stretch>
+        </p:blipFill>
+        <p:spPr>
+          <a:xfrm>
+            <a:off x="11017606" y="654710"/>
+            <a:ext cx="427939" cy="427939"/>
+          </a:xfrm>
+          <a:prstGeom prst="rect">
+            <a:avLst/>
+          </a:prstGeom>
+        </p:spPr>
+      </p:pic>
       <p:graphicFrame>
         <p:nvGraphicFramePr>
-          <p:cNvPr id="33" name="Table 0"/>
+          <p:cNvPr id="34" name="Table 0"/>
           <p:cNvGraphicFramePr>
             <a:graphicFrameLocks noGrp="1"/>
           </p:cNvGraphicFramePr>
@@ -21393,7 +22636,7 @@
                 <a:ea typeface="Calibri" pitchFamily="34" charset="-122"/>
                 <a:cs typeface="Calibri" pitchFamily="34" charset="-120"/>
               </a:rPr>
-              <a:t>32</a:t>
+              <a:t>33</a:t>
             </a:r>
             <a:endParaRPr lang="en-US" sz="900" dirty="0"/>
           </a:p>
@@ -21407,9 +22650,9 @@
 </p:sld>
 </file>
 
-<file path=ppt/slides/slide33.xml><?xml version="1.0" encoding="utf-8"?>
+<file path=ppt/slides/slide34.xml><?xml version="1.0" encoding="utf-8"?>
 <p:sld xmlns:a="http://schemas.openxmlformats.org/drawingml/2006/main" xmlns:r="http://schemas.openxmlformats.org/officeDocument/2006/relationships" xmlns:p="http://schemas.openxmlformats.org/presentationml/2006/main">
-  <p:cSld name="Slide 33">
+  <p:cSld name="Slide 34">
     <p:bg>
       <p:bgPr>
         <a:solidFill>

</xml_diff>